<commit_message>
fix: apply real brand colors (purple/cyan) to investor deck
Deck used an arbitrary teal accent instead of AdGrid's actual brand
tokens (purple #7B2FFF / cyan #00C2FF, unified with marketing site
per src/design/tokens.js). Swaps accent throughout both PPTX and the
HTML deck, adds brand gradient to hero pull-quotes, and switches font
references to Space Grotesk / JetBrains Mono to match the product.
</commit_message>
<xml_diff>
--- a/docs/investor/AdGrid-Seed-Deck.pptx
+++ b/docs/investor/AdGrid-Seed-Deck.pptx
@@ -4386,7 +4386,7 @@
           </a:prstGeom>
           <a:ln w="15240">
             <a:solidFill>
-              <a:srgbClr val="38E1C6"/>
+              <a:srgbClr val="9C5CFF"/>
             </a:solidFill>
           </a:ln>
         </p:spPr>
@@ -4435,9 +4435,9 @@
             <a:r>
               <a:rPr sz="1100" b="0">
                 <a:solidFill>
-                  <a:srgbClr val="38E1C6"/>
+                  <a:srgbClr val="9C5CFF"/>
                 </a:solidFill>
-                <a:latin typeface="Consolas"/>
+                <a:latin typeface="JetBrains Mono"/>
               </a:rPr>
               <a:t>SEED ROUND · $3.2M · 2026</a:t>
             </a:r>
@@ -4476,7 +4476,7 @@
                 <a:solidFill>
                   <a:srgbClr val="EDEFF3"/>
                 </a:solidFill>
-                <a:latin typeface="Arial Narrow"/>
+                <a:latin typeface="Space Grotesk"/>
               </a:rPr>
               <a:t>Every screen is a billboard.</a:t>
             </a:r>
@@ -4492,7 +4492,7 @@
                 <a:solidFill>
                   <a:srgbClr val="EDEFF3"/>
                 </a:solidFill>
-                <a:latin typeface="Arial Narrow"/>
+                <a:latin typeface="Space Grotesk"/>
               </a:rPr>
               <a:t>None of them are for sale.</a:t>
             </a:r>
@@ -4531,7 +4531,7 @@
                 <a:solidFill>
                   <a:srgbClr val="8D97AC"/>
                 </a:solidFill>
-                <a:latin typeface="Segoe UI"/>
+                <a:latin typeface="Space Grotesk"/>
               </a:rPr>
               <a:t>AdGrid is the self-serve marketplace that lets any business with a screen — a café, a gym, a laundromat, a lobby — sell ad space the same way Shopify let anyone sell a product. No sales calls, no IOs, no minimums.</a:t>
             </a:r>
@@ -4570,7 +4570,7 @@
                 <a:solidFill>
                   <a:srgbClr val="525C70"/>
                 </a:solidFill>
-                <a:latin typeface="Consolas"/>
+                <a:latin typeface="JetBrains Mono"/>
               </a:rPr>
               <a:t>ADGRID, INC.</a:t>
             </a:r>
@@ -4609,7 +4609,7 @@
                 <a:solidFill>
                   <a:srgbClr val="525C70"/>
                 </a:solidFill>
-                <a:latin typeface="Consolas"/>
+                <a:latin typeface="JetBrains Mono"/>
               </a:rPr>
               <a:t>CONFIDENTIAL — FOR INVESTOR REVIEW ONLY</a:t>
             </a:r>
@@ -4648,7 +4648,7 @@
                 <a:solidFill>
                   <a:srgbClr val="8D97AC"/>
                 </a:solidFill>
-                <a:latin typeface="Consolas"/>
+                <a:latin typeface="JetBrains Mono"/>
               </a:rPr>
               <a:t>01 / 14</a:t>
             </a:r>
@@ -6002,7 +6002,7 @@
           </a:prstGeom>
           <a:ln w="15240">
             <a:solidFill>
-              <a:srgbClr val="38E1C6"/>
+              <a:srgbClr val="9C5CFF"/>
             </a:solidFill>
           </a:ln>
         </p:spPr>
@@ -6051,9 +6051,9 @@
             <a:r>
               <a:rPr sz="1100" b="0">
                 <a:solidFill>
-                  <a:srgbClr val="38E1C6"/>
+                  <a:srgbClr val="9C5CFF"/>
                 </a:solidFill>
-                <a:latin typeface="Consolas"/>
+                <a:latin typeface="JetBrains Mono"/>
               </a:rPr>
               <a:t>BUSINESS MODEL</a:t>
             </a:r>
@@ -6092,7 +6092,7 @@
                 <a:solidFill>
                   <a:srgbClr val="EDEFF3"/>
                 </a:solidFill>
-                <a:latin typeface="Arial Narrow"/>
+                <a:latin typeface="Space Grotesk"/>
               </a:rPr>
               <a:t>Take rate on every transaction. No seat fees, no IOs.</a:t>
             </a:r>
@@ -6179,7 +6179,7 @@
                 <a:solidFill>
                   <a:srgbClr val="EDEFF3"/>
                 </a:solidFill>
-                <a:latin typeface="Segoe UI"/>
+                <a:latin typeface="Space Grotesk"/>
               </a:rPr>
               <a:t>Revenue</a:t>
             </a:r>
@@ -6218,7 +6218,7 @@
                 <a:solidFill>
                   <a:srgbClr val="8D97AC"/>
                 </a:solidFill>
-                <a:latin typeface="Segoe UI"/>
+                <a:latin typeface="Space Grotesk"/>
               </a:rPr>
               <a:t>A platform fee on every advertiser campaign, deducted before the operator payout. Scales directly with campaign volume — no separate SaaS tier to sell.</a:t>
             </a:r>
@@ -6257,7 +6257,7 @@
                 <a:solidFill>
                   <a:srgbClr val="8D97AC"/>
                 </a:solidFill>
-                <a:latin typeface="Segoe UI"/>
+                <a:latin typeface="Space Grotesk"/>
               </a:rPr>
               <a:t>Advertiser pays</a:t>
             </a:r>
@@ -6327,7 +6327,7 @@
             </a:avLst>
           </a:prstGeom>
           <a:solidFill>
-            <a:srgbClr val="1F7A6B"/>
+            <a:srgbClr val="7B2FFF"/>
           </a:solidFill>
           <a:ln>
             <a:noFill/>
@@ -6388,7 +6388,7 @@
                 <a:solidFill>
                   <a:srgbClr val="EDEFF3"/>
                 </a:solidFill>
-                <a:latin typeface="Consolas"/>
+                <a:latin typeface="JetBrains Mono"/>
               </a:rPr>
               <a:t>100%</a:t>
             </a:r>
@@ -6427,7 +6427,7 @@
                 <a:solidFill>
                   <a:srgbClr val="8D97AC"/>
                 </a:solidFill>
-                <a:latin typeface="Segoe UI"/>
+                <a:latin typeface="Space Grotesk"/>
               </a:rPr>
               <a:t>Operator payout</a:t>
             </a:r>
@@ -6497,7 +6497,7 @@
             </a:avLst>
           </a:prstGeom>
           <a:solidFill>
-            <a:srgbClr val="1F7A6B"/>
+            <a:srgbClr val="7B2FFF"/>
           </a:solidFill>
           <a:ln>
             <a:noFill/>
@@ -6558,7 +6558,7 @@
                 <a:solidFill>
                   <a:srgbClr val="EDEFF3"/>
                 </a:solidFill>
-                <a:latin typeface="Consolas"/>
+                <a:latin typeface="JetBrains Mono"/>
               </a:rPr>
               <a:t>~80%</a:t>
             </a:r>
@@ -6597,7 +6597,7 @@
                 <a:solidFill>
                   <a:srgbClr val="8D97AC"/>
                 </a:solidFill>
-                <a:latin typeface="Segoe UI"/>
+                <a:latin typeface="Space Grotesk"/>
               </a:rPr>
               <a:t>AdGrid take rate</a:t>
             </a:r>
@@ -6667,7 +6667,7 @@
             </a:avLst>
           </a:prstGeom>
           <a:solidFill>
-            <a:srgbClr val="FFB238"/>
+            <a:srgbClr val="F59E0B"/>
           </a:solidFill>
           <a:ln>
             <a:noFill/>
@@ -6728,7 +6728,7 @@
                 <a:solidFill>
                   <a:srgbClr val="EDEFF3"/>
                 </a:solidFill>
-                <a:latin typeface="Consolas"/>
+                <a:latin typeface="JetBrains Mono"/>
               </a:rPr>
               <a:t>~20%</a:t>
             </a:r>
@@ -6815,7 +6815,7 @@
                 <a:solidFill>
                   <a:srgbClr val="EDEFF3"/>
                 </a:solidFill>
-                <a:latin typeface="Segoe UI"/>
+                <a:latin typeface="Space Grotesk"/>
               </a:rPr>
               <a:t>Why self-serve compounds</a:t>
             </a:r>
@@ -6854,7 +6854,7 @@
                 <a:solidFill>
                   <a:srgbClr val="8D97AC"/>
                 </a:solidFill>
-                <a:latin typeface="Segoe UI"/>
+                <a:latin typeface="Space Grotesk"/>
               </a:rPr>
               <a:t>Every new screen is inventory with zero incremental sales cost. Every new advertiser is demand with zero incremental sales cost. Both sides onboard themselves — the marketplace gets denser, not more expensive to run.</a:t>
             </a:r>
@@ -6893,7 +6893,7 @@
                 <a:solidFill>
                   <a:srgbClr val="525C70"/>
                 </a:solidFill>
-                <a:latin typeface="Consolas"/>
+                <a:latin typeface="JetBrains Mono"/>
               </a:rPr>
               <a:t>ADGRID, INC.</a:t>
             </a:r>
@@ -6932,7 +6932,7 @@
                 <a:solidFill>
                   <a:srgbClr val="525C70"/>
                 </a:solidFill>
-                <a:latin typeface="Consolas"/>
+                <a:latin typeface="JetBrains Mono"/>
               </a:rPr>
               <a:t>CONFIDENTIAL — FOR INVESTOR REVIEW ONLY</a:t>
             </a:r>
@@ -6971,7 +6971,7 @@
                 <a:solidFill>
                   <a:srgbClr val="8D97AC"/>
                 </a:solidFill>
-                <a:latin typeface="Consolas"/>
+                <a:latin typeface="JetBrains Mono"/>
               </a:rPr>
               <a:t>10 / 14</a:t>
             </a:r>
@@ -8325,7 +8325,7 @@
           </a:prstGeom>
           <a:ln w="15240">
             <a:solidFill>
-              <a:srgbClr val="38E1C6"/>
+              <a:srgbClr val="9C5CFF"/>
             </a:solidFill>
           </a:ln>
         </p:spPr>
@@ -8374,9 +8374,9 @@
             <a:r>
               <a:rPr sz="1100" b="0">
                 <a:solidFill>
-                  <a:srgbClr val="38E1C6"/>
+                  <a:srgbClr val="9C5CFF"/>
                 </a:solidFill>
-                <a:latin typeface="Consolas"/>
+                <a:latin typeface="JetBrains Mono"/>
               </a:rPr>
               <a:t>THE ASK</a:t>
             </a:r>
@@ -8415,7 +8415,7 @@
                 <a:solidFill>
                   <a:srgbClr val="EDEFF3"/>
                 </a:solidFill>
-                <a:latin typeface="Arial Narrow"/>
+                <a:latin typeface="Space Grotesk"/>
               </a:rPr>
               <a:t>$3.2M seed to fund the team and the hardware kit that gets screens live faster.</a:t>
             </a:r>
@@ -8502,7 +8502,7 @@
                 <a:solidFill>
                   <a:srgbClr val="EDEFF3"/>
                 </a:solidFill>
-                <a:latin typeface="Segoe UI"/>
+                <a:latin typeface="Space Grotesk"/>
               </a:rPr>
               <a:t>Use of funds</a:t>
             </a:r>
@@ -8541,7 +8541,7 @@
                 <a:solidFill>
                   <a:srgbClr val="8D97AC"/>
                 </a:solidFill>
-                <a:latin typeface="Segoe UI"/>
+                <a:latin typeface="Space Grotesk"/>
               </a:rPr>
               <a:t/>
             </a:r>
@@ -8580,7 +8580,7 @@
                 <a:solidFill>
                   <a:srgbClr val="8D97AC"/>
                 </a:solidFill>
-                <a:latin typeface="Segoe UI"/>
+                <a:latin typeface="Space Grotesk"/>
               </a:rPr>
               <a:t>Engineering &amp; product team</a:t>
             </a:r>
@@ -8650,7 +8650,7 @@
             </a:avLst>
           </a:prstGeom>
           <a:solidFill>
-            <a:srgbClr val="1F7A6B"/>
+            <a:srgbClr val="7B2FFF"/>
           </a:solidFill>
           <a:ln>
             <a:noFill/>
@@ -8711,7 +8711,7 @@
                 <a:solidFill>
                   <a:srgbClr val="EDEFF3"/>
                 </a:solidFill>
-                <a:latin typeface="Consolas"/>
+                <a:latin typeface="JetBrains Mono"/>
               </a:rPr>
               <a:t>45%</a:t>
             </a:r>
@@ -8750,7 +8750,7 @@
                 <a:solidFill>
                   <a:srgbClr val="8D97AC"/>
                 </a:solidFill>
-                <a:latin typeface="Segoe UI"/>
+                <a:latin typeface="Space Grotesk"/>
               </a:rPr>
               <a:t>Operator hardware kits</a:t>
             </a:r>
@@ -8820,7 +8820,7 @@
             </a:avLst>
           </a:prstGeom>
           <a:solidFill>
-            <a:srgbClr val="1F7A6B"/>
+            <a:srgbClr val="7B2FFF"/>
           </a:solidFill>
           <a:ln>
             <a:noFill/>
@@ -8881,7 +8881,7 @@
                 <a:solidFill>
                   <a:srgbClr val="EDEFF3"/>
                 </a:solidFill>
-                <a:latin typeface="Consolas"/>
+                <a:latin typeface="JetBrains Mono"/>
               </a:rPr>
               <a:t>25%</a:t>
             </a:r>
@@ -8920,7 +8920,7 @@
                 <a:solidFill>
                   <a:srgbClr val="8D97AC"/>
                 </a:solidFill>
-                <a:latin typeface="Segoe UI"/>
+                <a:latin typeface="Space Grotesk"/>
               </a:rPr>
               <a:t>Go-to-market &amp; sales</a:t>
             </a:r>
@@ -8990,7 +8990,7 @@
             </a:avLst>
           </a:prstGeom>
           <a:solidFill>
-            <a:srgbClr val="1F7A6B"/>
+            <a:srgbClr val="7B2FFF"/>
           </a:solidFill>
           <a:ln>
             <a:noFill/>
@@ -9051,7 +9051,7 @@
                 <a:solidFill>
                   <a:srgbClr val="EDEFF3"/>
                 </a:solidFill>
-                <a:latin typeface="Consolas"/>
+                <a:latin typeface="JetBrains Mono"/>
               </a:rPr>
               <a:t>20%</a:t>
             </a:r>
@@ -9090,7 +9090,7 @@
                 <a:solidFill>
                   <a:srgbClr val="8D97AC"/>
                 </a:solidFill>
-                <a:latin typeface="Segoe UI"/>
+                <a:latin typeface="Space Grotesk"/>
               </a:rPr>
               <a:t>Ops &amp; runway buffer</a:t>
             </a:r>
@@ -9160,7 +9160,7 @@
             </a:avLst>
           </a:prstGeom>
           <a:solidFill>
-            <a:srgbClr val="1F7A6B"/>
+            <a:srgbClr val="7B2FFF"/>
           </a:solidFill>
           <a:ln>
             <a:noFill/>
@@ -9221,7 +9221,7 @@
                 <a:solidFill>
                   <a:srgbClr val="EDEFF3"/>
                 </a:solidFill>
-                <a:latin typeface="Consolas"/>
+                <a:latin typeface="JetBrains Mono"/>
               </a:rPr>
               <a:t>10%</a:t>
             </a:r>
@@ -9308,7 +9308,7 @@
                 <a:solidFill>
                   <a:srgbClr val="EDEFF3"/>
                 </a:solidFill>
-                <a:latin typeface="Segoe UI"/>
+                <a:latin typeface="Space Grotesk"/>
               </a:rPr>
               <a:t>The hardware kit</a:t>
             </a:r>
@@ -9347,7 +9347,7 @@
                 <a:solidFill>
                   <a:srgbClr val="8D97AC"/>
                 </a:solidFill>
-                <a:latin typeface="Segoe UI"/>
+                <a:latin typeface="Space Grotesk"/>
               </a:rPr>
               <a:t>Not custom displays — a standardized player box + mount that pairs with commodity screens an operator already owns. It turns “sign up” into “screen is live” without a truck roll or a technician. Removes the single biggest friction point in operator onboarding.</a:t>
             </a:r>
@@ -9386,7 +9386,7 @@
                 <a:solidFill>
                   <a:srgbClr val="525C70"/>
                 </a:solidFill>
-                <a:latin typeface="Consolas"/>
+                <a:latin typeface="JetBrains Mono"/>
               </a:rPr>
               <a:t>ADGRID, INC.</a:t>
             </a:r>
@@ -9425,7 +9425,7 @@
                 <a:solidFill>
                   <a:srgbClr val="525C70"/>
                 </a:solidFill>
-                <a:latin typeface="Consolas"/>
+                <a:latin typeface="JetBrains Mono"/>
               </a:rPr>
               <a:t>CONFIDENTIAL — FOR INVESTOR REVIEW ONLY</a:t>
             </a:r>
@@ -9464,7 +9464,7 @@
                 <a:solidFill>
                   <a:srgbClr val="8D97AC"/>
                 </a:solidFill>
-                <a:latin typeface="Consolas"/>
+                <a:latin typeface="JetBrains Mono"/>
               </a:rPr>
               <a:t>11 / 14</a:t>
             </a:r>
@@ -10818,7 +10818,7 @@
           </a:prstGeom>
           <a:ln w="15240">
             <a:solidFill>
-              <a:srgbClr val="38E1C6"/>
+              <a:srgbClr val="9C5CFF"/>
             </a:solidFill>
           </a:ln>
         </p:spPr>
@@ -10867,9 +10867,9 @@
             <a:r>
               <a:rPr sz="1100" b="0">
                 <a:solidFill>
-                  <a:srgbClr val="38E1C6"/>
+                  <a:srgbClr val="9C5CFF"/>
                 </a:solidFill>
-                <a:latin typeface="Consolas"/>
+                <a:latin typeface="JetBrains Mono"/>
               </a:rPr>
               <a:t>TEAM</a:t>
             </a:r>
@@ -10908,7 +10908,7 @@
                 <a:solidFill>
                   <a:srgbClr val="EDEFF3"/>
                 </a:solidFill>
-                <a:latin typeface="Arial Narrow"/>
+                <a:latin typeface="Space Grotesk"/>
               </a:rPr>
               <a:t>A founder-built platform, ready for a founding team.</a:t>
             </a:r>
@@ -10947,7 +10947,7 @@
                 <a:solidFill>
                   <a:srgbClr val="8D97AC"/>
                 </a:solidFill>
-                <a:latin typeface="Segoe UI"/>
+                <a:latin typeface="Space Grotesk"/>
               </a:rPr>
               <a:t>AdGrid is built and operated by a solo founder with contractor support today — the full advertiser and operator product, payments pipeline, and mobile app already shipped. This round funds the first full-time hires.</a:t>
             </a:r>
@@ -11034,7 +11034,7 @@
                 <a:solidFill>
                   <a:srgbClr val="EDEFF3"/>
                 </a:solidFill>
-                <a:latin typeface="Segoe UI"/>
+                <a:latin typeface="Space Grotesk"/>
               </a:rPr>
               <a:t>Founding engineer</a:t>
             </a:r>
@@ -11073,7 +11073,7 @@
                 <a:solidFill>
                   <a:srgbClr val="8D97AC"/>
                 </a:solidFill>
-                <a:latin typeface="Segoe UI"/>
+                <a:latin typeface="Space Grotesk"/>
               </a:rPr>
               <a:t>Owns the 90-day roadmap: measurement, payouts, security hardening.</a:t>
             </a:r>
@@ -11160,7 +11160,7 @@
                 <a:solidFill>
                   <a:srgbClr val="EDEFF3"/>
                 </a:solidFill>
-                <a:latin typeface="Segoe UI"/>
+                <a:latin typeface="Space Grotesk"/>
               </a:rPr>
               <a:t>Operator success / GTM</a:t>
             </a:r>
@@ -11199,7 +11199,7 @@
                 <a:solidFill>
                   <a:srgbClr val="8D97AC"/>
                 </a:solidFill>
-                <a:latin typeface="Segoe UI"/>
+                <a:latin typeface="Space Grotesk"/>
               </a:rPr>
               <a:t>Runs the hardware kit rollout and the first 100 operator signups by hand.</a:t>
             </a:r>
@@ -11286,7 +11286,7 @@
                 <a:solidFill>
                   <a:srgbClr val="EDEFF3"/>
                 </a:solidFill>
-                <a:latin typeface="Segoe UI"/>
+                <a:latin typeface="Space Grotesk"/>
               </a:rPr>
               <a:t>Founder (existing)</a:t>
             </a:r>
@@ -11325,7 +11325,7 @@
                 <a:solidFill>
                   <a:srgbClr val="8D97AC"/>
                 </a:solidFill>
-                <a:latin typeface="Segoe UI"/>
+                <a:latin typeface="Space Grotesk"/>
               </a:rPr>
               <a:t>Product, fundraising, and the first advertiser relationships.</a:t>
             </a:r>
@@ -11364,7 +11364,7 @@
                 <a:solidFill>
                   <a:srgbClr val="8D97AC"/>
                 </a:solidFill>
-                <a:latin typeface="Segoe UI"/>
+                <a:latin typeface="Space Grotesk"/>
               </a:rPr>
               <a:t>Hiring for the founding engineer and operator success roles begins within 30 days of close.</a:t>
             </a:r>
@@ -11403,7 +11403,7 @@
                 <a:solidFill>
                   <a:srgbClr val="525C70"/>
                 </a:solidFill>
-                <a:latin typeface="Consolas"/>
+                <a:latin typeface="JetBrains Mono"/>
               </a:rPr>
               <a:t>ADGRID, INC.</a:t>
             </a:r>
@@ -11442,7 +11442,7 @@
                 <a:solidFill>
                   <a:srgbClr val="525C70"/>
                 </a:solidFill>
-                <a:latin typeface="Consolas"/>
+                <a:latin typeface="JetBrains Mono"/>
               </a:rPr>
               <a:t>CONFIDENTIAL — FOR INVESTOR REVIEW ONLY</a:t>
             </a:r>
@@ -11481,7 +11481,7 @@
                 <a:solidFill>
                   <a:srgbClr val="8D97AC"/>
                 </a:solidFill>
-                <a:latin typeface="Consolas"/>
+                <a:latin typeface="JetBrains Mono"/>
               </a:rPr>
               <a:t>12 / 14</a:t>
             </a:r>
@@ -12835,7 +12835,7 @@
           </a:prstGeom>
           <a:ln w="15240">
             <a:solidFill>
-              <a:srgbClr val="38E1C6"/>
+              <a:srgbClr val="9C5CFF"/>
             </a:solidFill>
           </a:ln>
         </p:spPr>
@@ -12884,9 +12884,9 @@
             <a:r>
               <a:rPr sz="1100" b="0">
                 <a:solidFill>
-                  <a:srgbClr val="38E1C6"/>
+                  <a:srgbClr val="9C5CFF"/>
                 </a:solidFill>
-                <a:latin typeface="Consolas"/>
+                <a:latin typeface="JetBrains Mono"/>
               </a:rPr>
               <a:t>WHAT THIS ROUND BUYS</a:t>
             </a:r>
@@ -12925,7 +12925,7 @@
                 <a:solidFill>
                   <a:srgbClr val="EDEFF3"/>
                 </a:solidFill>
-                <a:latin typeface="Arial Narrow"/>
+                <a:latin typeface="Space Grotesk"/>
               </a:rPr>
               <a:t>18 months to a proven, self-serve, two-sided marketplace.</a:t>
             </a:r>
@@ -13001,7 +13001,7 @@
           </a:solidFill>
           <a:ln w="9525">
             <a:solidFill>
-              <a:srgbClr val="FFB238"/>
+              <a:srgbClr val="F59E0B"/>
             </a:solidFill>
           </a:ln>
         </p:spPr>
@@ -13027,9 +13027,9 @@
             <a:r>
               <a:rPr sz="800" b="1">
                 <a:solidFill>
-                  <a:srgbClr val="FFB238"/>
+                  <a:srgbClr val="F59E0B"/>
                 </a:solidFill>
-                <a:latin typeface="Consolas"/>
+                <a:latin typeface="JetBrains Mono"/>
               </a:rPr>
               <a:t>0–3 MO</a:t>
             </a:r>
@@ -13068,7 +13068,7 @@
                 <a:solidFill>
                   <a:srgbClr val="EDEFF3"/>
                 </a:solidFill>
-                <a:latin typeface="Segoe UI"/>
+                <a:latin typeface="Space Grotesk"/>
               </a:rPr>
               <a:t>Close the loop</a:t>
             </a:r>
@@ -13107,7 +13107,7 @@
                 <a:solidFill>
                   <a:srgbClr val="8D97AC"/>
                 </a:solidFill>
-                <a:latin typeface="Segoe UI"/>
+                <a:latin typeface="Space Grotesk"/>
               </a:rPr>
               <a:t>Measurement, payouts, and tenant security live in production. Public self-serve signup opens.</a:t>
             </a:r>
@@ -13146,7 +13146,7 @@
                 <a:solidFill>
                   <a:srgbClr val="525C70"/>
                 </a:solidFill>
-                <a:latin typeface="Consolas"/>
+                <a:latin typeface="JetBrains Mono"/>
               </a:rPr>
               <a:t>→</a:t>
             </a:r>
@@ -13222,7 +13222,7 @@
           </a:solidFill>
           <a:ln w="9525">
             <a:solidFill>
-              <a:srgbClr val="FFB238"/>
+              <a:srgbClr val="F59E0B"/>
             </a:solidFill>
           </a:ln>
         </p:spPr>
@@ -13248,9 +13248,9 @@
             <a:r>
               <a:rPr sz="800" b="1">
                 <a:solidFill>
-                  <a:srgbClr val="FFB238"/>
+                  <a:srgbClr val="F59E0B"/>
                 </a:solidFill>
-                <a:latin typeface="Consolas"/>
+                <a:latin typeface="JetBrains Mono"/>
               </a:rPr>
               <a:t>3–9 MO</a:t>
             </a:r>
@@ -13289,7 +13289,7 @@
                 <a:solidFill>
                   <a:srgbClr val="EDEFF3"/>
                 </a:solidFill>
-                <a:latin typeface="Segoe UI"/>
+                <a:latin typeface="Space Grotesk"/>
               </a:rPr>
               <a:t>Prove the wedge</a:t>
             </a:r>
@@ -13328,7 +13328,7 @@
                 <a:solidFill>
                   <a:srgbClr val="8D97AC"/>
                 </a:solidFill>
-                <a:latin typeface="Segoe UI"/>
+                <a:latin typeface="Space Grotesk"/>
               </a:rPr>
               <a:t>Hardware kit ships to first 100 operators across 3 GTM verticals. First recurring advertiser cohort.</a:t>
             </a:r>
@@ -13367,7 +13367,7 @@
                 <a:solidFill>
                   <a:srgbClr val="525C70"/>
                 </a:solidFill>
-                <a:latin typeface="Consolas"/>
+                <a:latin typeface="JetBrains Mono"/>
               </a:rPr>
               <a:t>→</a:t>
             </a:r>
@@ -13443,7 +13443,7 @@
           </a:solidFill>
           <a:ln w="9525">
             <a:solidFill>
-              <a:srgbClr val="38E1C6"/>
+              <a:srgbClr val="9C5CFF"/>
             </a:solidFill>
           </a:ln>
         </p:spPr>
@@ -13469,9 +13469,9 @@
             <a:r>
               <a:rPr sz="800" b="1">
                 <a:solidFill>
-                  <a:srgbClr val="38E1C6"/>
+                  <a:srgbClr val="9C5CFF"/>
                 </a:solidFill>
-                <a:latin typeface="Consolas"/>
+                <a:latin typeface="JetBrains Mono"/>
               </a:rPr>
               <a:t>9–18 MO</a:t>
             </a:r>
@@ -13510,7 +13510,7 @@
                 <a:solidFill>
                   <a:srgbClr val="EDEFF3"/>
                 </a:solidFill>
-                <a:latin typeface="Segoe UI"/>
+                <a:latin typeface="Space Grotesk"/>
               </a:rPr>
               <a:t>Scale the network</a:t>
             </a:r>
@@ -13549,7 +13549,7 @@
                 <a:solidFill>
                   <a:srgbClr val="8D97AC"/>
                 </a:solidFill>
-                <a:latin typeface="Segoe UI"/>
+                <a:latin typeface="Space Grotesk"/>
               </a:rPr>
               <a:t>Revenue run-rate and screen density sufficient to raise a Series A on real usage, not pilot data.</a:t>
             </a:r>
@@ -13588,7 +13588,7 @@
                 <a:solidFill>
                   <a:srgbClr val="8D97AC"/>
                 </a:solidFill>
-                <a:latin typeface="Segoe UI"/>
+                <a:latin typeface="Space Grotesk"/>
               </a:rPr>
               <a:t>Each stage is gated on the one before it — the roadmap only advances once measurement, payouts, and security are provably live, not just built.</a:t>
             </a:r>
@@ -13627,7 +13627,7 @@
                 <a:solidFill>
                   <a:srgbClr val="525C70"/>
                 </a:solidFill>
-                <a:latin typeface="Consolas"/>
+                <a:latin typeface="JetBrains Mono"/>
               </a:rPr>
               <a:t>ADGRID, INC.</a:t>
             </a:r>
@@ -13666,7 +13666,7 @@
                 <a:solidFill>
                   <a:srgbClr val="525C70"/>
                 </a:solidFill>
-                <a:latin typeface="Consolas"/>
+                <a:latin typeface="JetBrains Mono"/>
               </a:rPr>
               <a:t>CONFIDENTIAL — FOR INVESTOR REVIEW ONLY</a:t>
             </a:r>
@@ -13705,7 +13705,7 @@
                 <a:solidFill>
                   <a:srgbClr val="8D97AC"/>
                 </a:solidFill>
-                <a:latin typeface="Consolas"/>
+                <a:latin typeface="JetBrains Mono"/>
               </a:rPr>
               <a:t>13 / 14</a:t>
             </a:r>
@@ -15059,7 +15059,7 @@
           </a:prstGeom>
           <a:ln w="15240">
             <a:solidFill>
-              <a:srgbClr val="38E1C6"/>
+              <a:srgbClr val="9C5CFF"/>
             </a:solidFill>
           </a:ln>
         </p:spPr>
@@ -15108,9 +15108,9 @@
             <a:r>
               <a:rPr sz="1100" b="0">
                 <a:solidFill>
-                  <a:srgbClr val="38E1C6"/>
+                  <a:srgbClr val="9C5CFF"/>
                 </a:solidFill>
-                <a:latin typeface="Consolas"/>
+                <a:latin typeface="JetBrains Mono"/>
               </a:rPr>
               <a:t>THE CLOSE</a:t>
             </a:r>
@@ -15149,7 +15149,7 @@
                 <a:solidFill>
                   <a:srgbClr val="EDEFF3"/>
                 </a:solidFill>
-                <a:latin typeface="Arial Narrow"/>
+                <a:latin typeface="Space Grotesk"/>
               </a:rPr>
               <a:t>The DOOH giants just consolidated toward each other.</a:t>
             </a:r>
@@ -15186,9 +15186,9 @@
             <a:r>
               <a:rPr sz="3400" b="1">
                 <a:solidFill>
-                  <a:srgbClr val="38E1C6"/>
+                  <a:srgbClr val="9C5CFF"/>
                 </a:solidFill>
-                <a:latin typeface="Arial Narrow"/>
+                <a:latin typeface="Space Grotesk"/>
               </a:rPr>
               <a:t>We're building for everyone they left out.</a:t>
             </a:r>
@@ -15227,7 +15227,7 @@
                 <a:solidFill>
                   <a:srgbClr val="8D97AC"/>
                 </a:solidFill>
-                <a:latin typeface="Segoe UI"/>
+                <a:latin typeface="Space Grotesk"/>
               </a:rPr>
               <a:t>AdGrid · Seed round · $3.2M · gillsukhwinder9000@gmail.com</a:t>
             </a:r>
@@ -15266,7 +15266,7 @@
                 <a:solidFill>
                   <a:srgbClr val="525C70"/>
                 </a:solidFill>
-                <a:latin typeface="Consolas"/>
+                <a:latin typeface="JetBrains Mono"/>
               </a:rPr>
               <a:t>THANK YOU</a:t>
             </a:r>
@@ -15305,7 +15305,7 @@
                 <a:solidFill>
                   <a:srgbClr val="525C70"/>
                 </a:solidFill>
-                <a:latin typeface="Consolas"/>
+                <a:latin typeface="JetBrains Mono"/>
               </a:rPr>
               <a:t>CONFIDENTIAL — FOR INVESTOR REVIEW ONLY</a:t>
             </a:r>
@@ -15344,7 +15344,7 @@
                 <a:solidFill>
                   <a:srgbClr val="8D97AC"/>
                 </a:solidFill>
-                <a:latin typeface="Consolas"/>
+                <a:latin typeface="JetBrains Mono"/>
               </a:rPr>
               <a:t>14 / 14</a:t>
             </a:r>
@@ -16698,7 +16698,7 @@
           </a:prstGeom>
           <a:ln w="15240">
             <a:solidFill>
-              <a:srgbClr val="38E1C6"/>
+              <a:srgbClr val="9C5CFF"/>
             </a:solidFill>
           </a:ln>
         </p:spPr>
@@ -16747,9 +16747,9 @@
             <a:r>
               <a:rPr sz="1100" b="0">
                 <a:solidFill>
-                  <a:srgbClr val="38E1C6"/>
+                  <a:srgbClr val="9C5CFF"/>
                 </a:solidFill>
-                <a:latin typeface="Consolas"/>
+                <a:latin typeface="JetBrains Mono"/>
               </a:rPr>
               <a:t>THE SETUP</a:t>
             </a:r>
@@ -16788,7 +16788,7 @@
                 <a:solidFill>
                   <a:srgbClr val="EDEFF3"/>
                 </a:solidFill>
-                <a:latin typeface="Arial Narrow"/>
+                <a:latin typeface="Space Grotesk"/>
               </a:rPr>
               <a:t>Digital out-of-home just had its consolidation moment.</a:t>
             </a:r>
@@ -16827,7 +16827,7 @@
                 <a:solidFill>
                   <a:srgbClr val="8D97AC"/>
                 </a:solidFill>
-                <a:latin typeface="Segoe UI"/>
+                <a:latin typeface="Space Grotesk"/>
               </a:rPr>
               <a:t>Three acquisitions in the last twelve months collapsed the programmatic DOOH stack into a handful of enterprise players — and left the long tail of independent screen owners with nowhere to go.</a:t>
             </a:r>
@@ -16914,7 +16914,7 @@
                 <a:solidFill>
                   <a:srgbClr val="EDEFF3"/>
                 </a:solidFill>
-                <a:latin typeface="Segoe UI"/>
+                <a:latin typeface="Space Grotesk"/>
               </a:rPr>
               <a:t>Broadsign → acquires Place Exchange</a:t>
             </a:r>
@@ -16953,7 +16953,7 @@
                 <a:solidFill>
                   <a:srgbClr val="8D97AC"/>
                 </a:solidFill>
-                <a:latin typeface="Segoe UI"/>
+                <a:latin typeface="Space Grotesk"/>
               </a:rPr>
               <a:t>Nov 2025. Fourth M&amp;A in seven years. Now the largest DOOH platform — 1.8M screens, 370 employees.</a:t>
             </a:r>
@@ -17040,7 +17040,7 @@
                 <a:solidFill>
                   <a:srgbClr val="EDEFF3"/>
                 </a:solidFill>
-                <a:latin typeface="Segoe UI"/>
+                <a:latin typeface="Space Grotesk"/>
               </a:rPr>
               <a:t>T-Mobile → acquires Vistar Media</a:t>
             </a:r>
@@ -17079,7 +17079,7 @@
                 <a:solidFill>
                   <a:srgbClr val="8D97AC"/>
                 </a:solidFill>
-                <a:latin typeface="Segoe UI"/>
+                <a:latin typeface="Space Grotesk"/>
               </a:rPr>
               <a:t>The leading end-to-end DOOH SSP/DSP folded into a telco's ad business.</a:t>
             </a:r>
@@ -17166,7 +17166,7 @@
                 <a:solidFill>
                   <a:srgbClr val="EDEFF3"/>
                 </a:solidFill>
-                <a:latin typeface="Segoe UI"/>
+                <a:latin typeface="Space Grotesk"/>
               </a:rPr>
               <a:t>Perion → acquires Hivestack</a:t>
             </a:r>
@@ -17205,7 +17205,7 @@
                 <a:solidFill>
                   <a:srgbClr val="8D97AC"/>
                 </a:solidFill>
-                <a:latin typeface="Segoe UI"/>
+                <a:latin typeface="Space Grotesk"/>
               </a:rPr>
               <a:t>Another independent programmatic DOOH platform absorbed into a larger ad-tech holding co.</a:t>
             </a:r>
@@ -17244,7 +17244,7 @@
                 <a:solidFill>
                   <a:srgbClr val="EDEFF3"/>
                 </a:solidFill>
-                <a:latin typeface="Segoe UI"/>
+                <a:latin typeface="Space Grotesk"/>
               </a:rPr>
               <a:t>Every remaining platform sells to media buyers and national networks. None of them onboard a laundromat with one screen and a Wi-Fi router.</a:t>
             </a:r>
@@ -17283,7 +17283,7 @@
                 <a:solidFill>
                   <a:srgbClr val="525C70"/>
                 </a:solidFill>
-                <a:latin typeface="Consolas"/>
+                <a:latin typeface="JetBrains Mono"/>
               </a:rPr>
               <a:t>Source: invidis, Nov 2025 — Broadsign/Place Exchange, T-Mobile/Vistar Media, Perion/Hivestack deal coverage.</a:t>
             </a:r>
@@ -17322,7 +17322,7 @@
                 <a:solidFill>
                   <a:srgbClr val="525C70"/>
                 </a:solidFill>
-                <a:latin typeface="Consolas"/>
+                <a:latin typeface="JetBrains Mono"/>
               </a:rPr>
               <a:t>ADGRID, INC.</a:t>
             </a:r>
@@ -17361,7 +17361,7 @@
                 <a:solidFill>
                   <a:srgbClr val="525C70"/>
                 </a:solidFill>
-                <a:latin typeface="Consolas"/>
+                <a:latin typeface="JetBrains Mono"/>
               </a:rPr>
               <a:t>CONFIDENTIAL — FOR INVESTOR REVIEW ONLY</a:t>
             </a:r>
@@ -17400,7 +17400,7 @@
                 <a:solidFill>
                   <a:srgbClr val="8D97AC"/>
                 </a:solidFill>
-                <a:latin typeface="Consolas"/>
+                <a:latin typeface="JetBrains Mono"/>
               </a:rPr>
               <a:t>02 / 14</a:t>
             </a:r>
@@ -18754,7 +18754,7 @@
           </a:prstGeom>
           <a:ln w="15240">
             <a:solidFill>
-              <a:srgbClr val="38E1C6"/>
+              <a:srgbClr val="9C5CFF"/>
             </a:solidFill>
           </a:ln>
         </p:spPr>
@@ -18803,9 +18803,9 @@
             <a:r>
               <a:rPr sz="1100" b="0">
                 <a:solidFill>
-                  <a:srgbClr val="38E1C6"/>
+                  <a:srgbClr val="9C5CFF"/>
                 </a:solidFill>
-                <a:latin typeface="Consolas"/>
+                <a:latin typeface="JetBrains Mono"/>
               </a:rPr>
               <a:t>THE MARKET</a:t>
             </a:r>
@@ -18844,7 +18844,7 @@
                 <a:solidFill>
                   <a:srgbClr val="EDEFF3"/>
                 </a:solidFill>
-                <a:latin typeface="Arial Narrow"/>
+                <a:latin typeface="Space Grotesk"/>
               </a:rPr>
               <a:t>A $22B market, growing 12% a year — and the programmatic slice is growing faster still.</a:t>
             </a:r>
@@ -18881,9 +18881,9 @@
             <a:r>
               <a:rPr sz="3400" b="1">
                 <a:solidFill>
-                  <a:srgbClr val="FFB238"/>
+                  <a:srgbClr val="F59E0B"/>
                 </a:solidFill>
-                <a:latin typeface="Consolas"/>
+                <a:latin typeface="JetBrains Mono"/>
               </a:rPr>
               <a:t>$22.5B</a:t>
             </a:r>
@@ -18922,7 +18922,7 @@
                 <a:solidFill>
                   <a:srgbClr val="525C70"/>
                 </a:solidFill>
-                <a:latin typeface="Consolas"/>
+                <a:latin typeface="JetBrains Mono"/>
               </a:rPr>
               <a:t>GLOBAL DOOH AD SPEND, 2026</a:t>
             </a:r>
@@ -18959,9 +18959,9 @@
             <a:r>
               <a:rPr sz="3400" b="1">
                 <a:solidFill>
-                  <a:srgbClr val="FFB238"/>
+                  <a:srgbClr val="F59E0B"/>
                 </a:solidFill>
-                <a:latin typeface="Consolas"/>
+                <a:latin typeface="JetBrains Mono"/>
               </a:rPr>
               <a:t>$56.1B</a:t>
             </a:r>
@@ -19000,7 +19000,7 @@
                 <a:solidFill>
                   <a:srgbClr val="525C70"/>
                 </a:solidFill>
-                <a:latin typeface="Consolas"/>
+                <a:latin typeface="JetBrains Mono"/>
               </a:rPr>
               <a:t>PROJECTED DOOH SPEND, 2034 (12.1% CAGR)</a:t>
             </a:r>
@@ -19037,9 +19037,9 @@
             <a:r>
               <a:rPr sz="3400" b="1">
                 <a:solidFill>
-                  <a:srgbClr val="38E1C6"/>
+                  <a:srgbClr val="9C5CFF"/>
                 </a:solidFill>
-                <a:latin typeface="Consolas"/>
+                <a:latin typeface="JetBrains Mono"/>
               </a:rPr>
               <a:t>17.0%</a:t>
             </a:r>
@@ -19078,7 +19078,7 @@
                 <a:solidFill>
                   <a:srgbClr val="525C70"/>
                 </a:solidFill>
-                <a:latin typeface="Consolas"/>
+                <a:latin typeface="JetBrains Mono"/>
               </a:rPr>
               <a:t>CAGR OF THE PROGRAMMATIC DOOH PLATFORM LAYER</a:t>
             </a:r>
@@ -19117,7 +19117,7 @@
                 <a:solidFill>
                   <a:srgbClr val="8D97AC"/>
                 </a:solidFill>
-                <a:latin typeface="Segoe UI"/>
+                <a:latin typeface="Space Grotesk"/>
               </a:rPr>
               <a:t>Programmatic DOOH platform spend alone is projected to reach $12.9B by 2030. Almost none of that inventory comes from independently owned screens — because no self-serve rail exists to bring them on.</a:t>
             </a:r>
@@ -19204,7 +19204,7 @@
                 <a:solidFill>
                   <a:srgbClr val="EDEFF3"/>
                 </a:solidFill>
-                <a:latin typeface="Segoe UI"/>
+                <a:latin typeface="Space Grotesk"/>
               </a:rPr>
               <a:t>The gap this creates</a:t>
             </a:r>
@@ -19243,7 +19243,7 @@
                 <a:solidFill>
                   <a:srgbClr val="8D97AC"/>
                 </a:solidFill>
-                <a:latin typeface="Segoe UI"/>
+                <a:latin typeface="Space Grotesk"/>
               </a:rPr>
               <a:t>Programmatic platforms are built for national campaigns bought by media agencies. The tooling, minimums, and sales motion assume a buyer with a DSP seat and a screen network with a sales team — which excludes the millions of independently owned screens that have neither.</a:t>
             </a:r>
@@ -19282,7 +19282,7 @@
                 <a:solidFill>
                   <a:srgbClr val="525C70"/>
                 </a:solidFill>
-                <a:latin typeface="Consolas"/>
+                <a:latin typeface="JetBrains Mono"/>
               </a:rPr>
               <a:t>Sources: Fortune Business Insights; Research and Markets, Programmatic DOOH Platform Market Report, 2026.</a:t>
             </a:r>
@@ -19321,7 +19321,7 @@
                 <a:solidFill>
                   <a:srgbClr val="525C70"/>
                 </a:solidFill>
-                <a:latin typeface="Consolas"/>
+                <a:latin typeface="JetBrains Mono"/>
               </a:rPr>
               <a:t>ADGRID, INC.</a:t>
             </a:r>
@@ -19360,7 +19360,7 @@
                 <a:solidFill>
                   <a:srgbClr val="525C70"/>
                 </a:solidFill>
-                <a:latin typeface="Consolas"/>
+                <a:latin typeface="JetBrains Mono"/>
               </a:rPr>
               <a:t>CONFIDENTIAL — FOR INVESTOR REVIEW ONLY</a:t>
             </a:r>
@@ -19399,7 +19399,7 @@
                 <a:solidFill>
                   <a:srgbClr val="8D97AC"/>
                 </a:solidFill>
-                <a:latin typeface="Consolas"/>
+                <a:latin typeface="JetBrains Mono"/>
               </a:rPr>
               <a:t>03 / 14</a:t>
             </a:r>
@@ -20753,7 +20753,7 @@
           </a:prstGeom>
           <a:ln w="15240">
             <a:solidFill>
-              <a:srgbClr val="38E1C6"/>
+              <a:srgbClr val="9C5CFF"/>
             </a:solidFill>
           </a:ln>
         </p:spPr>
@@ -20802,9 +20802,9 @@
             <a:r>
               <a:rPr sz="1100" b="0">
                 <a:solidFill>
-                  <a:srgbClr val="38E1C6"/>
+                  <a:srgbClr val="9C5CFF"/>
                 </a:solidFill>
-                <a:latin typeface="Consolas"/>
+                <a:latin typeface="JetBrains Mono"/>
               </a:rPr>
               <a:t>THE SOLUTION</a:t>
             </a:r>
@@ -20843,7 +20843,7 @@
                 <a:solidFill>
                   <a:srgbClr val="EDEFF3"/>
                 </a:solidFill>
-                <a:latin typeface="Arial Narrow"/>
+                <a:latin typeface="Space Grotesk"/>
               </a:rPr>
               <a:t>A two-sided, self-serve marketplace — not another enterprise SSP.</a:t>
             </a:r>
@@ -20930,7 +20930,7 @@
                 <a:solidFill>
                   <a:srgbClr val="EDEFF3"/>
                 </a:solidFill>
-                <a:latin typeface="Segoe UI"/>
+                <a:latin typeface="Space Grotesk"/>
               </a:rPr>
               <a:t>For operators (screen owners)</a:t>
             </a:r>
@@ -20969,7 +20969,7 @@
                 <a:solidFill>
                   <a:srgbClr val="8D97AC"/>
                 </a:solidFill>
-                <a:latin typeface="Segoe UI"/>
+                <a:latin typeface="Space Grotesk"/>
               </a:rPr>
               <a:t>List a screen in minutes. AdGrid handles the player software, ad approval queue, and payout — the operator sets a floor price and gets paid.</a:t>
             </a:r>
@@ -20985,7 +20985,7 @@
                 <a:solidFill>
                   <a:srgbClr val="8D97AC"/>
                 </a:solidFill>
-                <a:latin typeface="Segoe UI"/>
+                <a:latin typeface="Space Grotesk"/>
               </a:rPr>
               <a:t/>
             </a:r>
@@ -21001,7 +21001,7 @@
                 <a:solidFill>
                   <a:srgbClr val="8D97AC"/>
                 </a:solidFill>
-                <a:latin typeface="Segoe UI"/>
+                <a:latin typeface="Space Grotesk"/>
               </a:rPr>
               <a:t>Built on the same product already live in the pilot network: onboarding wizard, approval queue, revenue dashboard.</a:t>
             </a:r>
@@ -21088,7 +21088,7 @@
                 <a:solidFill>
                   <a:srgbClr val="EDEFF3"/>
                 </a:solidFill>
-                <a:latin typeface="Segoe UI"/>
+                <a:latin typeface="Space Grotesk"/>
               </a:rPr>
               <a:t>For advertisers (any local business)</a:t>
             </a:r>
@@ -21127,7 +21127,7 @@
                 <a:solidFill>
                   <a:srgbClr val="8D97AC"/>
                 </a:solidFill>
-                <a:latin typeface="Segoe UI"/>
+                <a:latin typeface="Space Grotesk"/>
               </a:rPr>
               <a:t>A guided campaign wizard — pick an area, pick screens, set a budget, pay by card. No media buyer, no minimum spend, live in a day.</a:t>
             </a:r>
@@ -21143,7 +21143,7 @@
                 <a:solidFill>
                   <a:srgbClr val="8D97AC"/>
                 </a:solidFill>
-                <a:latin typeface="Segoe UI"/>
+                <a:latin typeface="Space Grotesk"/>
               </a:rPr>
               <a:t/>
             </a:r>
@@ -21159,7 +21159,7 @@
                 <a:solidFill>
                   <a:srgbClr val="8D97AC"/>
                 </a:solidFill>
-                <a:latin typeface="Segoe UI"/>
+                <a:latin typeface="Space Grotesk"/>
               </a:rPr>
               <a:t>Signup through pay-wall already runs end-to-end in production today.</a:t>
             </a:r>
@@ -21198,7 +21198,7 @@
                 <a:solidFill>
                   <a:srgbClr val="8D97AC"/>
                 </a:solidFill>
-                <a:latin typeface="Segoe UI"/>
+                <a:latin typeface="Space Grotesk"/>
               </a:rPr>
               <a:t>AdGrid takes a transaction fee on every campaign. No enterprise sales team, no IOs — the product is the sales motion.</a:t>
             </a:r>
@@ -21237,7 +21237,7 @@
                 <a:solidFill>
                   <a:srgbClr val="525C70"/>
                 </a:solidFill>
-                <a:latin typeface="Consolas"/>
+                <a:latin typeface="JetBrains Mono"/>
               </a:rPr>
               <a:t>ADGRID, INC.</a:t>
             </a:r>
@@ -21276,7 +21276,7 @@
                 <a:solidFill>
                   <a:srgbClr val="525C70"/>
                 </a:solidFill>
-                <a:latin typeface="Consolas"/>
+                <a:latin typeface="JetBrains Mono"/>
               </a:rPr>
               <a:t>CONFIDENTIAL — FOR INVESTOR REVIEW ONLY</a:t>
             </a:r>
@@ -21315,7 +21315,7 @@
                 <a:solidFill>
                   <a:srgbClr val="8D97AC"/>
                 </a:solidFill>
-                <a:latin typeface="Consolas"/>
+                <a:latin typeface="JetBrains Mono"/>
               </a:rPr>
               <a:t>04 / 14</a:t>
             </a:r>
@@ -22669,7 +22669,7 @@
           </a:prstGeom>
           <a:ln w="15240">
             <a:solidFill>
-              <a:srgbClr val="38E1C6"/>
+              <a:srgbClr val="9C5CFF"/>
             </a:solidFill>
           </a:ln>
         </p:spPr>
@@ -22718,9 +22718,9 @@
             <a:r>
               <a:rPr sz="1100" b="0">
                 <a:solidFill>
-                  <a:srgbClr val="38E1C6"/>
+                  <a:srgbClr val="9C5CFF"/>
                 </a:solidFill>
-                <a:latin typeface="Consolas"/>
+                <a:latin typeface="JetBrains Mono"/>
               </a:rPr>
               <a:t>HOW IT WORKS</a:t>
             </a:r>
@@ -22759,7 +22759,7 @@
                 <a:solidFill>
                   <a:srgbClr val="EDEFF3"/>
                 </a:solidFill>
-                <a:latin typeface="Arial Narrow"/>
+                <a:latin typeface="Space Grotesk"/>
               </a:rPr>
               <a:t>Money and measurement, closed loop.</a:t>
             </a:r>
@@ -22846,7 +22846,7 @@
                 <a:solidFill>
                   <a:srgbClr val="EDEFF3"/>
                 </a:solidFill>
-                <a:latin typeface="Segoe UI"/>
+                <a:latin typeface="Space Grotesk"/>
               </a:rPr>
               <a:t>Advertiser</a:t>
             </a:r>
@@ -22885,7 +22885,7 @@
                 <a:solidFill>
                   <a:srgbClr val="8D97AC"/>
                 </a:solidFill>
-                <a:latin typeface="Segoe UI"/>
+                <a:latin typeface="Space Grotesk"/>
               </a:rPr>
               <a:t>builds campaign, pays by card</a:t>
             </a:r>
@@ -22924,7 +22924,7 @@
                 <a:solidFill>
                   <a:srgbClr val="525C70"/>
                 </a:solidFill>
-                <a:latin typeface="Consolas"/>
+                <a:latin typeface="JetBrains Mono"/>
               </a:rPr>
               <a:t>→</a:t>
             </a:r>
@@ -23011,7 +23011,7 @@
                 <a:solidFill>
                   <a:srgbClr val="EDEFF3"/>
                 </a:solidFill>
-                <a:latin typeface="Segoe UI"/>
+                <a:latin typeface="Space Grotesk"/>
               </a:rPr>
               <a:t>AdGrid</a:t>
             </a:r>
@@ -23050,7 +23050,7 @@
                 <a:solidFill>
                   <a:srgbClr val="8D97AC"/>
                 </a:solidFill>
-                <a:latin typeface="Segoe UI"/>
+                <a:latin typeface="Space Grotesk"/>
               </a:rPr>
               <a:t>routes creative, holds funds</a:t>
             </a:r>
@@ -23089,7 +23089,7 @@
                 <a:solidFill>
                   <a:srgbClr val="525C70"/>
                 </a:solidFill>
-                <a:latin typeface="Consolas"/>
+                <a:latin typeface="JetBrains Mono"/>
               </a:rPr>
               <a:t>→</a:t>
             </a:r>
@@ -23176,7 +23176,7 @@
                 <a:solidFill>
                   <a:srgbClr val="EDEFF3"/>
                 </a:solidFill>
-                <a:latin typeface="Segoe UI"/>
+                <a:latin typeface="Space Grotesk"/>
               </a:rPr>
               <a:t>Screen</a:t>
             </a:r>
@@ -23215,7 +23215,7 @@
                 <a:solidFill>
                   <a:srgbClr val="8D97AC"/>
                 </a:solidFill>
-                <a:latin typeface="Segoe UI"/>
+                <a:latin typeface="Space Grotesk"/>
               </a:rPr>
               <a:t>plays creative, shows QR</a:t>
             </a:r>
@@ -23254,7 +23254,7 @@
                 <a:solidFill>
                   <a:srgbClr val="525C70"/>
                 </a:solidFill>
-                <a:latin typeface="Consolas"/>
+                <a:latin typeface="JetBrains Mono"/>
               </a:rPr>
               <a:t>→</a:t>
             </a:r>
@@ -23341,7 +23341,7 @@
                 <a:solidFill>
                   <a:srgbClr val="EDEFF3"/>
                 </a:solidFill>
-                <a:latin typeface="Segoe UI"/>
+                <a:latin typeface="Space Grotesk"/>
               </a:rPr>
               <a:t>Consumer scan</a:t>
             </a:r>
@@ -23380,7 +23380,7 @@
                 <a:solidFill>
                   <a:srgbClr val="8D97AC"/>
                 </a:solidFill>
-                <a:latin typeface="Segoe UI"/>
+                <a:latin typeface="Space Grotesk"/>
               </a:rPr>
               <a:t>tracked, then redirected</a:t>
             </a:r>
@@ -23467,7 +23467,7 @@
                 <a:solidFill>
                   <a:srgbClr val="EDEFF3"/>
                 </a:solidFill>
-                <a:latin typeface="Segoe UI"/>
+                <a:latin typeface="Space Grotesk"/>
               </a:rPr>
               <a:t>Scan data</a:t>
             </a:r>
@@ -23506,7 +23506,7 @@
                 <a:solidFill>
                   <a:srgbClr val="8D97AC"/>
                 </a:solidFill>
-                <a:latin typeface="Segoe UI"/>
+                <a:latin typeface="Space Grotesk"/>
               </a:rPr>
               <a:t>feeds advertiser dashboard + pixel forwarding (Meta / Google Conversions API)</a:t>
             </a:r>
@@ -23545,7 +23545,7 @@
                 <a:solidFill>
                   <a:srgbClr val="525C70"/>
                 </a:solidFill>
-                <a:latin typeface="Consolas"/>
+                <a:latin typeface="JetBrains Mono"/>
               </a:rPr>
               <a:t>→</a:t>
             </a:r>
@@ -23632,7 +23632,7 @@
                 <a:solidFill>
                   <a:srgbClr val="EDEFF3"/>
                 </a:solidFill>
-                <a:latin typeface="Segoe UI"/>
+                <a:latin typeface="Space Grotesk"/>
               </a:rPr>
               <a:t>Payout</a:t>
             </a:r>
@@ -23671,7 +23671,7 @@
                 <a:solidFill>
                   <a:srgbClr val="8D97AC"/>
                 </a:solidFill>
-                <a:latin typeface="Segoe UI"/>
+                <a:latin typeface="Space Grotesk"/>
               </a:rPr>
               <a:t>AdGrid keeps take rate, transfers the rest to the operator via Stripe Connect</a:t>
             </a:r>
@@ -23710,7 +23710,7 @@
                 <a:solidFill>
                   <a:srgbClr val="8D97AC"/>
                 </a:solidFill>
-                <a:latin typeface="Segoe UI"/>
+                <a:latin typeface="Space Grotesk"/>
               </a:rPr>
               <a:t>The advertiser only re-ups if the screen produced measurable scans. That closed loop — pay, play, prove, pay-out — is the whole product.</a:t>
             </a:r>
@@ -23749,7 +23749,7 @@
                 <a:solidFill>
                   <a:srgbClr val="525C70"/>
                 </a:solidFill>
-                <a:latin typeface="Consolas"/>
+                <a:latin typeface="JetBrains Mono"/>
               </a:rPr>
               <a:t>ADGRID, INC.</a:t>
             </a:r>
@@ -23788,7 +23788,7 @@
                 <a:solidFill>
                   <a:srgbClr val="525C70"/>
                 </a:solidFill>
-                <a:latin typeface="Consolas"/>
+                <a:latin typeface="JetBrains Mono"/>
               </a:rPr>
               <a:t>CONFIDENTIAL — FOR INVESTOR REVIEW ONLY</a:t>
             </a:r>
@@ -23827,7 +23827,7 @@
                 <a:solidFill>
                   <a:srgbClr val="8D97AC"/>
                 </a:solidFill>
-                <a:latin typeface="Consolas"/>
+                <a:latin typeface="JetBrains Mono"/>
               </a:rPr>
               <a:t>05 / 14</a:t>
             </a:r>
@@ -25181,7 +25181,7 @@
           </a:prstGeom>
           <a:ln w="15240">
             <a:solidFill>
-              <a:srgbClr val="38E1C6"/>
+              <a:srgbClr val="9C5CFF"/>
             </a:solidFill>
           </a:ln>
         </p:spPr>
@@ -25230,9 +25230,9 @@
             <a:r>
               <a:rPr sz="1100" b="0">
                 <a:solidFill>
-                  <a:srgbClr val="38E1C6"/>
+                  <a:srgbClr val="9C5CFF"/>
                 </a:solidFill>
-                <a:latin typeface="Consolas"/>
+                <a:latin typeface="JetBrains Mono"/>
               </a:rPr>
               <a:t>WHERE WE ACTUALLY ARE</a:t>
             </a:r>
@@ -25271,7 +25271,7 @@
                 <a:solidFill>
                   <a:srgbClr val="EDEFF3"/>
                 </a:solidFill>
-                <a:latin typeface="Arial Narrow"/>
+                <a:latin typeface="Space Grotesk"/>
               </a:rPr>
               <a:t>Built, piloted, and verified — with a named punch list before public launch.</a:t>
             </a:r>
@@ -25310,7 +25310,7 @@
                 <a:solidFill>
                   <a:srgbClr val="8D97AC"/>
                 </a:solidFill>
-                <a:latin typeface="Segoe UI"/>
+                <a:latin typeface="Space Grotesk"/>
               </a:rPr>
               <a:t>We ran a live verification pass against production data this month. Here's the real state, not the pitch version.</a:t>
             </a:r>
@@ -25349,7 +25349,7 @@
                 <a:solidFill>
                   <a:srgbClr val="EDEFF3"/>
                 </a:solidFill>
-                <a:latin typeface="Consolas"/>
+                <a:latin typeface="JetBrains Mono"/>
               </a:rPr>
               <a:t>12</a:t>
             </a:r>
@@ -25388,7 +25388,7 @@
                 <a:solidFill>
                   <a:srgbClr val="525C70"/>
                 </a:solidFill>
-                <a:latin typeface="Consolas"/>
+                <a:latin typeface="JetBrains Mono"/>
               </a:rPr>
               <a:t>SCREENS ONBOARDED (PILOT NETWORK)</a:t>
             </a:r>
@@ -25427,7 +25427,7 @@
                 <a:solidFill>
                   <a:srgbClr val="EDEFF3"/>
                 </a:solidFill>
-                <a:latin typeface="Consolas"/>
+                <a:latin typeface="JetBrains Mono"/>
               </a:rPr>
               <a:t>8</a:t>
             </a:r>
@@ -25466,7 +25466,7 @@
                 <a:solidFill>
                   <a:srgbClr val="525C70"/>
                 </a:solidFill>
-                <a:latin typeface="Consolas"/>
+                <a:latin typeface="JetBrains Mono"/>
               </a:rPr>
               <a:t>SCREENS LIVE IN PRODUCTION</a:t>
             </a:r>
@@ -25505,7 +25505,7 @@
                 <a:solidFill>
                   <a:srgbClr val="EDEFF3"/>
                 </a:solidFill>
-                <a:latin typeface="Consolas"/>
+                <a:latin typeface="JetBrains Mono"/>
               </a:rPr>
               <a:t>2</a:t>
             </a:r>
@@ -25544,7 +25544,7 @@
                 <a:solidFill>
                   <a:srgbClr val="525C70"/>
                 </a:solidFill>
-                <a:latin typeface="Consolas"/>
+                <a:latin typeface="JetBrains Mono"/>
               </a:rPr>
               <a:t>OPERATOR PARTNERS TRANSACTING</a:t>
             </a:r>
@@ -25620,7 +25620,7 @@
           </a:solidFill>
           <a:ln w="9525">
             <a:solidFill>
-              <a:srgbClr val="38E1C6"/>
+              <a:srgbClr val="9C5CFF"/>
             </a:solidFill>
           </a:ln>
         </p:spPr>
@@ -25646,9 +25646,9 @@
             <a:r>
               <a:rPr sz="800" b="1">
                 <a:solidFill>
-                  <a:srgbClr val="38E1C6"/>
+                  <a:srgbClr val="9C5CFF"/>
                 </a:solidFill>
-                <a:latin typeface="Consolas"/>
+                <a:latin typeface="JetBrains Mono"/>
               </a:rPr>
               <a:t>PROVEN LIVE</a:t>
             </a:r>
@@ -25687,7 +25687,7 @@
                 <a:solidFill>
                   <a:srgbClr val="EDEFF3"/>
                 </a:solidFill>
-                <a:latin typeface="Segoe UI"/>
+                <a:latin typeface="Space Grotesk"/>
               </a:rPr>
               <a:t>Proven live</a:t>
             </a:r>
@@ -25726,7 +25726,7 @@
                 <a:solidFill>
                   <a:srgbClr val="8D97AC"/>
                 </a:solidFill>
-                <a:latin typeface="Segoe UI"/>
+                <a:latin typeface="Space Grotesk"/>
               </a:rPr>
               <a:t>Advertiser signup → 5-step campaign wizard → review → pay-wall runs end-to-end on real infrastructure. Screen onboarding, approval queue, and role-based dashboards all work.</a:t>
             </a:r>
@@ -25802,7 +25802,7 @@
           </a:solidFill>
           <a:ln w="9525">
             <a:solidFill>
-              <a:srgbClr val="FFB238"/>
+              <a:srgbClr val="F59E0B"/>
             </a:solidFill>
           </a:ln>
         </p:spPr>
@@ -25828,9 +25828,9 @@
             <a:r>
               <a:rPr sz="800" b="1">
                 <a:solidFill>
-                  <a:srgbClr val="FFB238"/>
+                  <a:srgbClr val="F59E0B"/>
                 </a:solidFill>
-                <a:latin typeface="Consolas"/>
+                <a:latin typeface="JetBrains Mono"/>
               </a:rPr>
               <a:t>FUNDED ROADMAP</a:t>
             </a:r>
@@ -25869,7 +25869,7 @@
                 <a:solidFill>
                   <a:srgbClr val="EDEFF3"/>
                 </a:solidFill>
-                <a:latin typeface="Segoe UI"/>
+                <a:latin typeface="Space Grotesk"/>
               </a:rPr>
               <a:t>Funded roadmap</a:t>
             </a:r>
@@ -25908,7 +25908,7 @@
                 <a:solidFill>
                   <a:srgbClr val="8D97AC"/>
                 </a:solidFill>
-                <a:latin typeface="Segoe UI"/>
+                <a:latin typeface="Space Grotesk"/>
               </a:rPr>
               <a:t>Scan tracking, operator payouts, and tenant data isolation are built but not yet wired end-to-end in production. This is the first 90 days of engineering the round funds.</a:t>
             </a:r>
@@ -25947,7 +25947,7 @@
                 <a:solidFill>
                   <a:srgbClr val="525C70"/>
                 </a:solidFill>
-                <a:latin typeface="Consolas"/>
+                <a:latin typeface="JetBrains Mono"/>
               </a:rPr>
               <a:t>ADGRID, INC.</a:t>
             </a:r>
@@ -25986,7 +25986,7 @@
                 <a:solidFill>
                   <a:srgbClr val="525C70"/>
                 </a:solidFill>
-                <a:latin typeface="Consolas"/>
+                <a:latin typeface="JetBrains Mono"/>
               </a:rPr>
               <a:t>CONFIDENTIAL — FOR INVESTOR REVIEW ONLY</a:t>
             </a:r>
@@ -26025,7 +26025,7 @@
                 <a:solidFill>
                   <a:srgbClr val="8D97AC"/>
                 </a:solidFill>
-                <a:latin typeface="Consolas"/>
+                <a:latin typeface="JetBrains Mono"/>
               </a:rPr>
               <a:t>06 / 14</a:t>
             </a:r>
@@ -27379,7 +27379,7 @@
           </a:prstGeom>
           <a:ln w="15240">
             <a:solidFill>
-              <a:srgbClr val="38E1C6"/>
+              <a:srgbClr val="9C5CFF"/>
             </a:solidFill>
           </a:ln>
         </p:spPr>
@@ -27428,9 +27428,9 @@
             <a:r>
               <a:rPr sz="1100" b="0">
                 <a:solidFill>
-                  <a:srgbClr val="38E1C6"/>
+                  <a:srgbClr val="9C5CFF"/>
                 </a:solidFill>
-                <a:latin typeface="Consolas"/>
+                <a:latin typeface="JetBrains Mono"/>
               </a:rPr>
               <a:t>90-DAY ROADMAP</a:t>
             </a:r>
@@ -27469,7 +27469,7 @@
                 <a:solidFill>
                   <a:srgbClr val="EDEFF3"/>
                 </a:solidFill>
-                <a:latin typeface="Arial Narrow"/>
+                <a:latin typeface="Space Grotesk"/>
               </a:rPr>
               <a:t>Three fixes stand between pilot and self-serve public launch.</a:t>
             </a:r>
@@ -27556,7 +27556,7 @@
                 <a:solidFill>
                   <a:srgbClr val="EDEFF3"/>
                 </a:solidFill>
-                <a:latin typeface="Segoe UI"/>
+                <a:latin typeface="Space Grotesk"/>
               </a:rPr>
               <a:t>Activate scan-based measurement</a:t>
             </a:r>
@@ -27595,7 +27595,7 @@
                 <a:solidFill>
                   <a:srgbClr val="8D97AC"/>
                 </a:solidFill>
-                <a:latin typeface="Segoe UI"/>
+                <a:latin typeface="Space Grotesk"/>
               </a:rPr>
               <a:t>QR redirect + pixel-forwarding service is built and tested in isolation. Repoint the on-screen QR through it so every scan is counted — this is the product's headline metric.</a:t>
             </a:r>
@@ -27623,7 +27623,7 @@
           </a:solidFill>
           <a:ln w="9525">
             <a:solidFill>
-              <a:srgbClr val="FFB238"/>
+              <a:srgbClr val="F59E0B"/>
             </a:solidFill>
           </a:ln>
           <a:effectLst/>
@@ -27650,9 +27650,9 @@
             <a:r>
               <a:rPr sz="900" b="1">
                 <a:solidFill>
-                  <a:srgbClr val="FFB238"/>
+                  <a:srgbClr val="F59E0B"/>
                 </a:solidFill>
-                <a:latin typeface="Consolas"/>
+                <a:latin typeface="JetBrains Mono"/>
               </a:rPr>
               <a:t>WEEKS 1–3</a:t>
             </a:r>
@@ -27739,7 +27739,7 @@
                 <a:solidFill>
                   <a:srgbClr val="EDEFF3"/>
                 </a:solidFill>
-                <a:latin typeface="Segoe UI"/>
+                <a:latin typeface="Space Grotesk"/>
               </a:rPr>
               <a:t>Turn on operator payouts</a:t>
             </a:r>
@@ -27778,7 +27778,7 @@
                 <a:solidFill>
                   <a:srgbClr val="8D97AC"/>
                 </a:solidFill>
-                <a:latin typeface="Segoe UI"/>
+                <a:latin typeface="Space Grotesk"/>
               </a:rPr>
               <a:t>Stripe Connect integration exists in the charge pipeline. Make onboarding a required step so operator transfers actually execute, not just advertiser charges.</a:t>
             </a:r>
@@ -27806,7 +27806,7 @@
           </a:solidFill>
           <a:ln w="9525">
             <a:solidFill>
-              <a:srgbClr val="FFB238"/>
+              <a:srgbClr val="F59E0B"/>
             </a:solidFill>
           </a:ln>
           <a:effectLst/>
@@ -27833,9 +27833,9 @@
             <a:r>
               <a:rPr sz="900" b="1">
                 <a:solidFill>
-                  <a:srgbClr val="FFB238"/>
+                  <a:srgbClr val="F59E0B"/>
                 </a:solidFill>
-                <a:latin typeface="Consolas"/>
+                <a:latin typeface="JetBrains Mono"/>
               </a:rPr>
               <a:t>WEEKS 2–5</a:t>
             </a:r>
@@ -27922,7 +27922,7 @@
                 <a:solidFill>
                   <a:srgbClr val="EDEFF3"/>
                 </a:solidFill>
-                <a:latin typeface="Segoe UI"/>
+                <a:latin typeface="Space Grotesk"/>
               </a:rPr>
               <a:t>Harden tenant data isolation</a:t>
             </a:r>
@@ -27961,7 +27961,7 @@
                 <a:solidFill>
                   <a:srgbClr val="8D97AC"/>
                 </a:solidFill>
-                <a:latin typeface="Segoe UI"/>
+                <a:latin typeface="Space Grotesk"/>
               </a:rPr>
               <a:t>Scope operator revenue and internal fields out of advertiser-facing data access. Security review before any self-serve public signup.</a:t>
             </a:r>
@@ -27989,7 +27989,7 @@
           </a:solidFill>
           <a:ln w="9525">
             <a:solidFill>
-              <a:srgbClr val="FFB238"/>
+              <a:srgbClr val="F59E0B"/>
             </a:solidFill>
           </a:ln>
           <a:effectLst/>
@@ -28016,9 +28016,9 @@
             <a:r>
               <a:rPr sz="900" b="1">
                 <a:solidFill>
-                  <a:srgbClr val="FFB238"/>
+                  <a:srgbClr val="F59E0B"/>
                 </a:solidFill>
-                <a:latin typeface="Consolas"/>
+                <a:latin typeface="JetBrains Mono"/>
               </a:rPr>
               <a:t>WEEKS 1–2</a:t>
             </a:r>
@@ -28057,7 +28057,7 @@
                 <a:solidFill>
                   <a:srgbClr val="8D97AC"/>
                 </a:solidFill>
-                <a:latin typeface="Segoe UI"/>
+                <a:latin typeface="Space Grotesk"/>
               </a:rPr>
               <a:t>These are scoped, known, and estimated — not open-ended risk. This is exactly the work a funded engineering team clears before opening the doors.</a:t>
             </a:r>
@@ -28096,7 +28096,7 @@
                 <a:solidFill>
                   <a:srgbClr val="525C70"/>
                 </a:solidFill>
-                <a:latin typeface="Consolas"/>
+                <a:latin typeface="JetBrains Mono"/>
               </a:rPr>
               <a:t>ADGRID, INC.</a:t>
             </a:r>
@@ -28135,7 +28135,7 @@
                 <a:solidFill>
                   <a:srgbClr val="525C70"/>
                 </a:solidFill>
-                <a:latin typeface="Consolas"/>
+                <a:latin typeface="JetBrains Mono"/>
               </a:rPr>
               <a:t>CONFIDENTIAL — FOR INVESTOR REVIEW ONLY</a:t>
             </a:r>
@@ -28174,7 +28174,7 @@
                 <a:solidFill>
                   <a:srgbClr val="8D97AC"/>
                 </a:solidFill>
-                <a:latin typeface="Consolas"/>
+                <a:latin typeface="JetBrains Mono"/>
               </a:rPr>
               <a:t>07 / 14</a:t>
             </a:r>
@@ -29528,7 +29528,7 @@
           </a:prstGeom>
           <a:ln w="15240">
             <a:solidFill>
-              <a:srgbClr val="38E1C6"/>
+              <a:srgbClr val="9C5CFF"/>
             </a:solidFill>
           </a:ln>
         </p:spPr>
@@ -29577,9 +29577,9 @@
             <a:r>
               <a:rPr sz="1100" b="0">
                 <a:solidFill>
-                  <a:srgbClr val="38E1C6"/>
+                  <a:srgbClr val="9C5CFF"/>
                 </a:solidFill>
-                <a:latin typeface="Consolas"/>
+                <a:latin typeface="JetBrains Mono"/>
               </a:rPr>
               <a:t>GO-TO-MARKET</a:t>
             </a:r>
@@ -29618,7 +29618,7 @@
                 <a:solidFill>
                   <a:srgbClr val="EDEFF3"/>
                 </a:solidFill>
-                <a:latin typeface="Arial Narrow"/>
+                <a:latin typeface="Space Grotesk"/>
               </a:rPr>
               <a:t>Start where nobody else will sell direct.</a:t>
             </a:r>
@@ -29705,7 +29705,7 @@
                 <a:solidFill>
                   <a:srgbClr val="EDEFF3"/>
                 </a:solidFill>
-                <a:latin typeface="Segoe UI"/>
+                <a:latin typeface="Space Grotesk"/>
               </a:rPr>
               <a:t>Cafés &amp; laundromats</a:t>
             </a:r>
@@ -29744,7 +29744,7 @@
                 <a:solidFill>
                   <a:srgbClr val="8D97AC"/>
                 </a:solidFill>
-                <a:latin typeface="Segoe UI"/>
+                <a:latin typeface="Space Grotesk"/>
               </a:rPr>
               <a:t>High dwell time, zero sales-team coverage today.</a:t>
             </a:r>
@@ -29831,7 +29831,7 @@
                 <a:solidFill>
                   <a:srgbClr val="EDEFF3"/>
                 </a:solidFill>
-                <a:latin typeface="Segoe UI"/>
+                <a:latin typeface="Space Grotesk"/>
               </a:rPr>
               <a:t>Gyms &amp; studios</a:t>
             </a:r>
@@ -29870,7 +29870,7 @@
                 <a:solidFill>
                   <a:srgbClr val="8D97AC"/>
                 </a:solidFill>
-                <a:latin typeface="Segoe UI"/>
+                <a:latin typeface="Space Grotesk"/>
               </a:rPr>
               <a:t>Captive local audience, existing screen hardware.</a:t>
             </a:r>
@@ -29957,7 +29957,7 @@
                 <a:solidFill>
                   <a:srgbClr val="EDEFF3"/>
                 </a:solidFill>
-                <a:latin typeface="Segoe UI"/>
+                <a:latin typeface="Space Grotesk"/>
               </a:rPr>
               <a:t>Elevator &amp; lobby</a:t>
             </a:r>
@@ -29996,7 +29996,7 @@
                 <a:solidFill>
                   <a:srgbClr val="8D97AC"/>
                 </a:solidFill>
-                <a:latin typeface="Segoe UI"/>
+                <a:latin typeface="Space Grotesk"/>
               </a:rPr>
               <a:t>Property managers, one screen per building, easy repeat.</a:t>
             </a:r>
@@ -30083,7 +30083,7 @@
                 <a:solidFill>
                   <a:srgbClr val="EDEFF3"/>
                 </a:solidFill>
-                <a:latin typeface="Segoe UI"/>
+                <a:latin typeface="Space Grotesk"/>
               </a:rPr>
               <a:t>Local retail chains</a:t>
             </a:r>
@@ -30122,7 +30122,7 @@
                 <a:solidFill>
                   <a:srgbClr val="8D97AC"/>
                 </a:solidFill>
-                <a:latin typeface="Segoe UI"/>
+                <a:latin typeface="Space Grotesk"/>
               </a:rPr>
               <a:t>Multi-location owners = multi-screen operators in one signup.</a:t>
             </a:r>
@@ -30161,7 +30161,7 @@
                 <a:solidFill>
                   <a:srgbClr val="8D97AC"/>
                 </a:solidFill>
-                <a:latin typeface="Segoe UI"/>
+                <a:latin typeface="Space Grotesk"/>
               </a:rPr>
               <a:t>Every enterprise DOOH platform requires a media-buyer relationship to transact. AdGrid requires a credit card. That's the wedge into the segment the consolidation just abandoned.</a:t>
             </a:r>
@@ -30200,7 +30200,7 @@
                 <a:solidFill>
                   <a:srgbClr val="525C70"/>
                 </a:solidFill>
-                <a:latin typeface="Consolas"/>
+                <a:latin typeface="JetBrains Mono"/>
               </a:rPr>
               <a:t>ADGRID, INC.</a:t>
             </a:r>
@@ -30239,7 +30239,7 @@
                 <a:solidFill>
                   <a:srgbClr val="525C70"/>
                 </a:solidFill>
-                <a:latin typeface="Consolas"/>
+                <a:latin typeface="JetBrains Mono"/>
               </a:rPr>
               <a:t>CONFIDENTIAL — FOR INVESTOR REVIEW ONLY</a:t>
             </a:r>
@@ -30278,7 +30278,7 @@
                 <a:solidFill>
                   <a:srgbClr val="8D97AC"/>
                 </a:solidFill>
-                <a:latin typeface="Consolas"/>
+                <a:latin typeface="JetBrains Mono"/>
               </a:rPr>
               <a:t>08 / 14</a:t>
             </a:r>
@@ -31632,7 +31632,7 @@
           </a:prstGeom>
           <a:ln w="15240">
             <a:solidFill>
-              <a:srgbClr val="38E1C6"/>
+              <a:srgbClr val="9C5CFF"/>
             </a:solidFill>
           </a:ln>
         </p:spPr>
@@ -31681,9 +31681,9 @@
             <a:r>
               <a:rPr sz="1100" b="0">
                 <a:solidFill>
-                  <a:srgbClr val="38E1C6"/>
+                  <a:srgbClr val="9C5CFF"/>
                 </a:solidFill>
-                <a:latin typeface="Consolas"/>
+                <a:latin typeface="JetBrains Mono"/>
               </a:rPr>
               <a:t>COMPETITIVE LANDSCAPE</a:t>
             </a:r>
@@ -31722,7 +31722,7 @@
                 <a:solidFill>
                   <a:srgbClr val="EDEFF3"/>
                 </a:solidFill>
-                <a:latin typeface="Arial Narrow"/>
+                <a:latin typeface="Space Grotesk"/>
               </a:rPr>
               <a:t>Nobody else is self-serve on both sides.</a:t>
             </a:r>
@@ -31761,7 +31761,7 @@
                 <a:solidFill>
                   <a:srgbClr val="525C70"/>
                 </a:solidFill>
-                <a:latin typeface="Consolas"/>
+                <a:latin typeface="JetBrains Mono"/>
               </a:rPr>
               <a:t>PLATFORM</a:t>
             </a:r>
@@ -31800,7 +31800,7 @@
                 <a:solidFill>
                   <a:srgbClr val="525C70"/>
                 </a:solidFill>
-                <a:latin typeface="Consolas"/>
+                <a:latin typeface="JetBrains Mono"/>
               </a:rPr>
               <a:t>BUYER ONBOARDING</a:t>
             </a:r>
@@ -31839,7 +31839,7 @@
                 <a:solidFill>
                   <a:srgbClr val="525C70"/>
                 </a:solidFill>
-                <a:latin typeface="Consolas"/>
+                <a:latin typeface="JetBrains Mono"/>
               </a:rPr>
               <a:t>SCREEN OWNER ONBOARDING</a:t>
             </a:r>
@@ -31878,7 +31878,7 @@
                 <a:solidFill>
                   <a:srgbClr val="525C70"/>
                 </a:solidFill>
-                <a:latin typeface="Consolas"/>
+                <a:latin typeface="JetBrains Mono"/>
               </a:rPr>
               <a:t>MINIMUM SPEND</a:t>
             </a:r>
@@ -31952,7 +31952,7 @@
                 <a:solidFill>
                   <a:srgbClr val="8D97AC"/>
                 </a:solidFill>
-                <a:latin typeface="Segoe UI"/>
+                <a:latin typeface="Space Grotesk"/>
               </a:rPr>
               <a:t>Broadsign + Place Exchange</a:t>
             </a:r>
@@ -31991,7 +31991,7 @@
                 <a:solidFill>
                   <a:srgbClr val="8D97AC"/>
                 </a:solidFill>
-                <a:latin typeface="Segoe UI"/>
+                <a:latin typeface="Space Grotesk"/>
               </a:rPr>
               <a:t>Media buyer / DSP seat</a:t>
             </a:r>
@@ -32030,7 +32030,7 @@
                 <a:solidFill>
                   <a:srgbClr val="8D97AC"/>
                 </a:solidFill>
-                <a:latin typeface="Segoe UI"/>
+                <a:latin typeface="Space Grotesk"/>
               </a:rPr>
               <a:t>Sales-assisted</a:t>
             </a:r>
@@ -32069,7 +32069,7 @@
                 <a:solidFill>
                   <a:srgbClr val="8D97AC"/>
                 </a:solidFill>
-                <a:latin typeface="Segoe UI"/>
+                <a:latin typeface="Space Grotesk"/>
               </a:rPr>
               <a:t>Enterprise IOs</a:t>
             </a:r>
@@ -32143,7 +32143,7 @@
                 <a:solidFill>
                   <a:srgbClr val="8D97AC"/>
                 </a:solidFill>
-                <a:latin typeface="Segoe UI"/>
+                <a:latin typeface="Space Grotesk"/>
               </a:rPr>
               <a:t>Vistar Media (T-Mobile)</a:t>
             </a:r>
@@ -32182,7 +32182,7 @@
                 <a:solidFill>
                   <a:srgbClr val="8D97AC"/>
                 </a:solidFill>
-                <a:latin typeface="Segoe UI"/>
+                <a:latin typeface="Space Grotesk"/>
               </a:rPr>
               <a:t>Media buyer / DSP seat</a:t>
             </a:r>
@@ -32221,7 +32221,7 @@
                 <a:solidFill>
                   <a:srgbClr val="8D97AC"/>
                 </a:solidFill>
-                <a:latin typeface="Segoe UI"/>
+                <a:latin typeface="Space Grotesk"/>
               </a:rPr>
               <a:t>Sales-assisted</a:t>
             </a:r>
@@ -32260,7 +32260,7 @@
                 <a:solidFill>
                   <a:srgbClr val="8D97AC"/>
                 </a:solidFill>
-                <a:latin typeface="Segoe UI"/>
+                <a:latin typeface="Space Grotesk"/>
               </a:rPr>
               <a:t>Enterprise IOs</a:t>
             </a:r>
@@ -32334,7 +32334,7 @@
                 <a:solidFill>
                   <a:srgbClr val="8D97AC"/>
                 </a:solidFill>
-                <a:latin typeface="Segoe UI"/>
+                <a:latin typeface="Space Grotesk"/>
               </a:rPr>
               <a:t>Hivestack (Perion)</a:t>
             </a:r>
@@ -32373,7 +32373,7 @@
                 <a:solidFill>
                   <a:srgbClr val="8D97AC"/>
                 </a:solidFill>
-                <a:latin typeface="Segoe UI"/>
+                <a:latin typeface="Space Grotesk"/>
               </a:rPr>
               <a:t>Media buyer / DSP seat</a:t>
             </a:r>
@@ -32412,7 +32412,7 @@
                 <a:solidFill>
                   <a:srgbClr val="8D97AC"/>
                 </a:solidFill>
-                <a:latin typeface="Segoe UI"/>
+                <a:latin typeface="Space Grotesk"/>
               </a:rPr>
               <a:t>Sales-assisted</a:t>
             </a:r>
@@ -32451,7 +32451,7 @@
                 <a:solidFill>
                   <a:srgbClr val="8D97AC"/>
                 </a:solidFill>
-                <a:latin typeface="Segoe UI"/>
+                <a:latin typeface="Space Grotesk"/>
               </a:rPr>
               <a:t>Enterprise IOs</a:t>
             </a:r>
@@ -32567,9 +32567,9 @@
             <a:r>
               <a:rPr sz="1200" b="1">
                 <a:solidFill>
-                  <a:srgbClr val="38E1C6"/>
+                  <a:srgbClr val="9C5CFF"/>
                 </a:solidFill>
-                <a:latin typeface="Segoe UI"/>
+                <a:latin typeface="Space Grotesk"/>
               </a:rPr>
               <a:t>AdGrid</a:t>
             </a:r>
@@ -32608,7 +32608,7 @@
                 <a:solidFill>
                   <a:srgbClr val="EDEFF3"/>
                 </a:solidFill>
-                <a:latin typeface="Segoe UI"/>
+                <a:latin typeface="Space Grotesk"/>
               </a:rPr>
               <a:t>Self-serve, card on file</a:t>
             </a:r>
@@ -32647,7 +32647,7 @@
                 <a:solidFill>
                   <a:srgbClr val="EDEFF3"/>
                 </a:solidFill>
-                <a:latin typeface="Segoe UI"/>
+                <a:latin typeface="Space Grotesk"/>
               </a:rPr>
               <a:t>Self-serve, screen + Wi-Fi</a:t>
             </a:r>
@@ -32686,7 +32686,7 @@
                 <a:solidFill>
                   <a:srgbClr val="EDEFF3"/>
                 </a:solidFill>
-                <a:latin typeface="Segoe UI"/>
+                <a:latin typeface="Space Grotesk"/>
               </a:rPr>
               <a:t>None</a:t>
             </a:r>
@@ -32760,7 +32760,7 @@
                 <a:solidFill>
                   <a:srgbClr val="8D97AC"/>
                 </a:solidFill>
-                <a:latin typeface="Segoe UI"/>
+                <a:latin typeface="Space Grotesk"/>
               </a:rPr>
               <a:t>This isn't a claim we're better at their game. It's that their game requires a sales team on both sides — and the market they just consolidated around doesn't include the screens that don't have one.</a:t>
             </a:r>
@@ -32847,7 +32847,7 @@
                 <a:solidFill>
                   <a:srgbClr val="EDEFF3"/>
                 </a:solidFill>
-                <a:latin typeface="Segoe UI"/>
+                <a:latin typeface="Space Grotesk"/>
               </a:rPr>
               <a:t>Why this doesn't stay open long</a:t>
             </a:r>
@@ -32886,7 +32886,7 @@
                 <a:solidFill>
                   <a:srgbClr val="8D97AC"/>
                 </a:solidFill>
-                <a:latin typeface="Segoe UI"/>
+                <a:latin typeface="Space Grotesk"/>
               </a:rPr>
               <a:t>Consolidation makes the wedge bigger, not smaller — three fewer independent platforms to compete with for the self-serve segment.</a:t>
             </a:r>
@@ -32925,7 +32925,7 @@
                 <a:solidFill>
                   <a:srgbClr val="525C70"/>
                 </a:solidFill>
-                <a:latin typeface="Consolas"/>
+                <a:latin typeface="JetBrains Mono"/>
               </a:rPr>
               <a:t>ADGRID, INC.</a:t>
             </a:r>
@@ -32964,7 +32964,7 @@
                 <a:solidFill>
                   <a:srgbClr val="525C70"/>
                 </a:solidFill>
-                <a:latin typeface="Consolas"/>
+                <a:latin typeface="JetBrains Mono"/>
               </a:rPr>
               <a:t>CONFIDENTIAL — FOR INVESTOR REVIEW ONLY</a:t>
             </a:r>
@@ -33003,7 +33003,7 @@
                 <a:solidFill>
                   <a:srgbClr val="8D97AC"/>
                 </a:solidFill>
-                <a:latin typeface="Consolas"/>
+                <a:latin typeface="JetBrains Mono"/>
               </a:rPr>
               <a:t>09 / 14</a:t>
             </a:r>

</xml_diff>